<commit_message>
fix(PART_2): Remove empty title placeholders and fix text overflow in slides
</commit_message>
<xml_diff>
--- a/PART_2/Capstone-Three_Presentation_v2.pptx
+++ b/PART_2/Capstone-Three_Presentation_v2.pptx
@@ -3108,23 +3108,6 @@
       <p:grpSpPr/>
       <p:sp>
         <p:nvSpPr>
-          <p:cNvPr id="2" name="Title 1"/>
-          <p:cNvSpPr>
-            <a:spLocks noGrp="1"/>
-          </p:cNvSpPr>
-          <p:nvPr>
-            <p:ph type="title"/>
-          </p:nvPr>
-        </p:nvSpPr>
-        <p:spPr/>
-        <p:txBody>
-          <a:bodyPr/>
-          <a:lstStyle/>
-          <a:p/>
-        </p:txBody>
-      </p:sp>
-      <p:sp>
-        <p:nvSpPr>
           <p:cNvPr id="3" name="TextBox 2"/>
           <p:cNvSpPr txBox="1"/>
           <p:nvPr/>
@@ -3140,7 +3123,7 @@
           <a:noFill/>
         </p:spPr>
         <p:txBody>
-          <a:bodyPr wrap="none">
+          <a:bodyPr wrap="square">
             <a:spAutoFit/>
           </a:bodyPr>
           <a:lstStyle/>
@@ -3203,23 +3186,6 @@
       <p:grpSpPr/>
       <p:sp>
         <p:nvSpPr>
-          <p:cNvPr id="2" name="Title 1"/>
-          <p:cNvSpPr>
-            <a:spLocks noGrp="1"/>
-          </p:cNvSpPr>
-          <p:nvPr>
-            <p:ph type="title"/>
-          </p:nvPr>
-        </p:nvSpPr>
-        <p:spPr/>
-        <p:txBody>
-          <a:bodyPr/>
-          <a:lstStyle/>
-          <a:p/>
-        </p:txBody>
-      </p:sp>
-      <p:sp>
-        <p:nvSpPr>
           <p:cNvPr id="3" name="TextBox 2"/>
           <p:cNvSpPr txBox="1"/>
           <p:nvPr/>
@@ -3403,23 +3369,6 @@
       <p:grpSpPr/>
       <p:sp>
         <p:nvSpPr>
-          <p:cNvPr id="2" name="Title 1"/>
-          <p:cNvSpPr>
-            <a:spLocks noGrp="1"/>
-          </p:cNvSpPr>
-          <p:nvPr>
-            <p:ph type="title"/>
-          </p:nvPr>
-        </p:nvSpPr>
-        <p:spPr/>
-        <p:txBody>
-          <a:bodyPr/>
-          <a:lstStyle/>
-          <a:p/>
-        </p:txBody>
-      </p:sp>
-      <p:sp>
-        <p:nvSpPr>
           <p:cNvPr id="3" name="TextBox 2"/>
           <p:cNvSpPr txBox="1"/>
           <p:nvPr/>
@@ -3470,7 +3419,7 @@
         <p:spPr>
           <a:xfrm>
             <a:off x="1371600" y="1371600"/>
-            <a:ext cx="9144000" cy="5678254"/>
+            <a:ext cx="9144000" cy="5212080"/>
           </a:xfrm>
           <a:prstGeom prst="rect">
             <a:avLst/>
@@ -3497,23 +3446,6 @@
       <p:grpSpPr/>
       <p:sp>
         <p:nvSpPr>
-          <p:cNvPr id="2" name="Title 1"/>
-          <p:cNvSpPr>
-            <a:spLocks noGrp="1"/>
-          </p:cNvSpPr>
-          <p:nvPr>
-            <p:ph type="title"/>
-          </p:nvPr>
-        </p:nvSpPr>
-        <p:spPr/>
-        <p:txBody>
-          <a:bodyPr/>
-          <a:lstStyle/>
-          <a:p/>
-        </p:txBody>
-      </p:sp>
-      <p:sp>
-        <p:nvSpPr>
           <p:cNvPr id="3" name="TextBox 2"/>
           <p:cNvSpPr txBox="1"/>
           <p:nvPr/>
@@ -3591,23 +3523,6 @@
       <p:grpSpPr/>
       <p:sp>
         <p:nvSpPr>
-          <p:cNvPr id="2" name="Title 1"/>
-          <p:cNvSpPr>
-            <a:spLocks noGrp="1"/>
-          </p:cNvSpPr>
-          <p:nvPr>
-            <p:ph type="title"/>
-          </p:nvPr>
-        </p:nvSpPr>
-        <p:spPr/>
-        <p:txBody>
-          <a:bodyPr/>
-          <a:lstStyle/>
-          <a:p/>
-        </p:txBody>
-      </p:sp>
-      <p:sp>
-        <p:nvSpPr>
           <p:cNvPr id="3" name="TextBox 2"/>
           <p:cNvSpPr txBox="1"/>
           <p:nvPr/>
@@ -3758,23 +3673,6 @@
       <p:grpSpPr/>
       <p:sp>
         <p:nvSpPr>
-          <p:cNvPr id="2" name="Title 1"/>
-          <p:cNvSpPr>
-            <a:spLocks noGrp="1"/>
-          </p:cNvSpPr>
-          <p:nvPr>
-            <p:ph type="title"/>
-          </p:nvPr>
-        </p:nvSpPr>
-        <p:spPr/>
-        <p:txBody>
-          <a:bodyPr/>
-          <a:lstStyle/>
-          <a:p/>
-        </p:txBody>
-      </p:sp>
-      <p:sp>
-        <p:nvSpPr>
           <p:cNvPr id="3" name="TextBox 2"/>
           <p:cNvSpPr txBox="1"/>
           <p:nvPr/>
@@ -3973,6 +3871,83 @@
           </a:p>
         </p:txBody>
       </p:sp>
+    </p:spTree>
+  </p:cSld>
+  <p:clrMapOvr>
+    <a:masterClrMapping/>
+  </p:clrMapOvr>
+</p:sld>
+</file>
+
+<file path=ppt/slides/slide15.xml><?xml version="1.0" encoding="utf-8"?>
+<p:sld xmlns:a="http://schemas.openxmlformats.org/drawingml/2006/main" xmlns:p="http://schemas.openxmlformats.org/presentationml/2006/main" xmlns:r="http://schemas.openxmlformats.org/officeDocument/2006/relationships">
+  <p:cSld>
+    <p:spTree>
+      <p:nvGrpSpPr>
+        <p:cNvPr id="1" name=""/>
+        <p:cNvGrpSpPr/>
+        <p:nvPr/>
+      </p:nvGrpSpPr>
+      <p:grpSpPr/>
+      <p:sp>
+        <p:nvSpPr>
+          <p:cNvPr id="3" name="TextBox 2"/>
+          <p:cNvSpPr txBox="1"/>
+          <p:nvPr/>
+        </p:nvSpPr>
+        <p:spPr>
+          <a:xfrm>
+            <a:off x="457200" y="274320"/>
+            <a:ext cx="10972800" cy="914400"/>
+          </a:xfrm>
+          <a:prstGeom prst="rect">
+            <a:avLst/>
+          </a:prstGeom>
+          <a:noFill/>
+        </p:spPr>
+        <p:txBody>
+          <a:bodyPr wrap="square">
+            <a:spAutoFit/>
+          </a:bodyPr>
+          <a:lstStyle/>
+          <a:p>
+            <a:pPr>
+              <a:defRPr sz="3200" b="1">
+                <a:solidFill>
+                  <a:srgbClr val="2C3E50"/>
+                </a:solidFill>
+              </a:defRPr>
+            </a:pPr>
+            <a:r>
+              <a:t>Conclusions</a:t>
+            </a:r>
+          </a:p>
+        </p:txBody>
+      </p:sp>
+      <p:pic>
+        <p:nvPicPr>
+          <p:cNvPr id="4" name="Picture 3" descr="key_conclusions.png"/>
+          <p:cNvPicPr>
+            <a:picLocks noChangeAspect="1"/>
+          </p:cNvPicPr>
+          <p:nvPr/>
+        </p:nvPicPr>
+        <p:blipFill>
+          <a:blip r:embed="rId2"/>
+          <a:stretch>
+            <a:fillRect/>
+          </a:stretch>
+        </p:blipFill>
+        <p:spPr>
+          <a:xfrm>
+            <a:off x="1371600" y="1371600"/>
+            <a:ext cx="9144000" cy="5212080"/>
+          </a:xfrm>
+          <a:prstGeom prst="rect">
+            <a:avLst/>
+          </a:prstGeom>
+        </p:spPr>
+      </p:pic>
     </p:spTree>
   </p:cSld>
   <p:clrMapOvr>
@@ -3993,23 +3968,6 @@
       <p:grpSpPr/>
       <p:sp>
         <p:nvSpPr>
-          <p:cNvPr id="2" name="Title 1"/>
-          <p:cNvSpPr>
-            <a:spLocks noGrp="1"/>
-          </p:cNvSpPr>
-          <p:nvPr>
-            <p:ph type="title"/>
-          </p:nvPr>
-        </p:nvSpPr>
-        <p:spPr/>
-        <p:txBody>
-          <a:bodyPr/>
-          <a:lstStyle/>
-          <a:p/>
-        </p:txBody>
-      </p:sp>
-      <p:sp>
-        <p:nvSpPr>
           <p:cNvPr id="3" name="TextBox 2"/>
           <p:cNvSpPr txBox="1"/>
           <p:nvPr/>
@@ -4038,35 +3996,111 @@
               </a:defRPr>
             </a:pPr>
             <a:r>
-              <a:t>Conclusions</a:t>
-            </a:r>
-          </a:p>
-        </p:txBody>
-      </p:sp>
-      <p:pic>
-        <p:nvPicPr>
-          <p:cNvPr id="4" name="Picture 3" descr="key_conclusions.png"/>
-          <p:cNvPicPr>
-            <a:picLocks noChangeAspect="1"/>
-          </p:cNvPicPr>
+              <a:t>Future Directions</a:t>
+            </a:r>
+          </a:p>
+        </p:txBody>
+      </p:sp>
+      <p:sp>
+        <p:nvSpPr>
+          <p:cNvPr id="4" name="TextBox 3"/>
+          <p:cNvSpPr txBox="1"/>
           <p:nvPr/>
-        </p:nvPicPr>
-        <p:blipFill>
-          <a:blip r:embed="rId2"/>
-          <a:stretch>
-            <a:fillRect/>
-          </a:stretch>
-        </p:blipFill>
-        <p:spPr>
-          <a:xfrm>
-            <a:off x="1371600" y="1371600"/>
-            <a:ext cx="9144000" cy="5455612"/>
+        </p:nvSpPr>
+        <p:spPr>
+          <a:xfrm>
+            <a:off x="457200" y="1371600"/>
+            <a:ext cx="10972800" cy="5029200"/>
           </a:xfrm>
           <a:prstGeom prst="rect">
             <a:avLst/>
           </a:prstGeom>
-        </p:spPr>
-      </p:pic>
+          <a:noFill/>
+        </p:spPr>
+        <p:txBody>
+          <a:bodyPr wrap="square">
+            <a:spAutoFit/>
+          </a:bodyPr>
+          <a:lstStyle/>
+          <a:p>
+            <a:pPr>
+              <a:spcAft>
+                <a:spcPts val="1000"/>
+              </a:spcAft>
+              <a:defRPr sz="1800"/>
+            </a:pPr>
+            <a:r>
+              <a:t>• 5-Fold Cross-Validation for confidence intervals</a:t>
+            </a:r>
+          </a:p>
+          <a:p>
+            <a:pPr>
+              <a:spcAft>
+                <a:spcPts val="1000"/>
+              </a:spcAft>
+              <a:defRPr sz="1800"/>
+            </a:pPr>
+            <a:r>
+              <a:t>• Multi-center data from additional institutions/scanners</a:t>
+            </a:r>
+          </a:p>
+          <a:p>
+            <a:pPr>
+              <a:spcAft>
+                <a:spcPts val="1000"/>
+              </a:spcAft>
+              <a:defRPr sz="1800"/>
+            </a:pPr>
+            <a:r>
+              <a:t>• Transfer learning / medical imaging foundation models</a:t>
+            </a:r>
+          </a:p>
+          <a:p>
+            <a:pPr>
+              <a:spcAft>
+                <a:spcPts val="1000"/>
+              </a:spcAft>
+              <a:defRPr sz="1800"/>
+            </a:pPr>
+            <a:r>
+              <a:t>• Contrastive self-supervised pretraining</a:t>
+            </a:r>
+          </a:p>
+          <a:p>
+            <a:pPr>
+              <a:spcAft>
+                <a:spcPts val="1000"/>
+              </a:spcAft>
+              <a:defRPr sz="1800"/>
+            </a:pPr>
+            <a:r>
+              <a:t>• Grad-CAM explainability for clinical trust</a:t>
+            </a:r>
+          </a:p>
+          <a:p>
+            <a:pPr>
+              <a:spcAft>
+                <a:spcPts val="1000"/>
+              </a:spcAft>
+              <a:defRPr sz="1800"/>
+            </a:pPr>
+            <a:r>
+              <a:t>• Ensemble methods across architectures</a:t>
+            </a:r>
+          </a:p>
+          <a:p>
+            <a:pPr>
+              <a:spcAft>
+                <a:spcPts val="1000"/>
+              </a:spcAft>
+              <a:defRPr sz="1800"/>
+            </a:pPr>
+            <a:r>
+              <a:t>• Web application deployment (Gradio/HuggingFace)</a:t>
+            </a:r>
+          </a:p>
+        </p:txBody>
+      </p:sp>
     </p:spTree>
   </p:cSld>
   <p:clrMapOvr>
@@ -4087,23 +4121,6 @@
       <p:grpSpPr/>
       <p:sp>
         <p:nvSpPr>
-          <p:cNvPr id="2" name="Title 1"/>
-          <p:cNvSpPr>
-            <a:spLocks noGrp="1"/>
-          </p:cNvSpPr>
-          <p:nvPr>
-            <p:ph type="title"/>
-          </p:nvPr>
-        </p:nvSpPr>
-        <p:spPr/>
-        <p:txBody>
-          <a:bodyPr/>
-          <a:lstStyle/>
-          <a:p/>
-        </p:txBody>
-      </p:sp>
-      <p:sp>
-        <p:nvSpPr>
           <p:cNvPr id="3" name="TextBox 2"/>
           <p:cNvSpPr txBox="1"/>
           <p:nvPr/>
@@ -4132,7 +4149,7 @@
               </a:defRPr>
             </a:pPr>
             <a:r>
-              <a:t>Future Directions</a:t>
+              <a:t>Project Structure</a:t>
             </a:r>
           </a:p>
         </p:txBody>
@@ -4166,73 +4183,114 @@
               <a:defRPr sz="1800"/>
             </a:pPr>
             <a:r>
-              <a:t>• 5-Fold Cross-Validation for confidence intervals</a:t>
-            </a:r>
-          </a:p>
-          <a:p>
-            <a:pPr>
-              <a:spcAft>
-                <a:spcPts val="1000"/>
-              </a:spcAft>
-              <a:defRPr sz="1800"/>
-            </a:pPr>
-            <a:r>
-              <a:t>• Multi-center data from additional institutions/scanners</a:t>
-            </a:r>
-          </a:p>
-          <a:p>
-            <a:pPr>
-              <a:spcAft>
-                <a:spcPts val="1000"/>
-              </a:spcAft>
-              <a:defRPr sz="1800"/>
-            </a:pPr>
-            <a:r>
-              <a:t>• Transfer learning / medical imaging foundation models</a:t>
-            </a:r>
-          </a:p>
-          <a:p>
-            <a:pPr>
-              <a:spcAft>
-                <a:spcPts val="1000"/>
-              </a:spcAft>
-              <a:defRPr sz="1800"/>
-            </a:pPr>
-            <a:r>
-              <a:t>• Contrastive self-supervised pretraining</a:t>
-            </a:r>
-          </a:p>
-          <a:p>
-            <a:pPr>
-              <a:spcAft>
-                <a:spcPts val="1000"/>
-              </a:spcAft>
-              <a:defRPr sz="1800"/>
-            </a:pPr>
-            <a:r>
-              <a:t>• Grad-CAM explainability for clinical trust</a:t>
-            </a:r>
-          </a:p>
-          <a:p>
-            <a:pPr>
-              <a:spcAft>
-                <a:spcPts val="1000"/>
-              </a:spcAft>
-              <a:defRPr sz="1800"/>
-            </a:pPr>
-            <a:r>
-              <a:t>• Ensemble methods across architectures</a:t>
-            </a:r>
-          </a:p>
-          <a:p>
-            <a:pPr>
-              <a:spcAft>
-                <a:spcPts val="1000"/>
-              </a:spcAft>
-              <a:defRPr sz="1800"/>
-            </a:pPr>
-            <a:r>
-              <a:t>• Web application deployment (Gradio/HuggingFace)</a:t>
+              <a:t>PART_2/</a:t>
+            </a:r>
+          </a:p>
+          <a:p>
+            <a:pPr>
+              <a:spcAft>
+                <a:spcPts val="1000"/>
+              </a:spcAft>
+              <a:defRPr sz="1800"/>
+            </a:pPr>
+            <a:r>
+              <a:t>  ├─ DW-EDA.ipynb            Data wrangling &amp; EDA</a:t>
+            </a:r>
+          </a:p>
+          <a:p>
+            <a:pPr>
+              <a:spcAft>
+                <a:spcPts val="1000"/>
+              </a:spcAft>
+              <a:defRPr sz="1800"/>
+            </a:pPr>
+            <a:r>
+              <a:t>  ├─ PPs-Modeling.ipynb      Preprocessing + Modeling</a:t>
+            </a:r>
+          </a:p>
+          <a:p>
+            <a:pPr>
+              <a:spcAft>
+                <a:spcPts val="1000"/>
+              </a:spcAft>
+              <a:defRPr sz="1800"/>
+            </a:pPr>
+            <a:r>
+              <a:t>  ├─ model_metrics.json      Model metrics file</a:t>
+            </a:r>
+          </a:p>
+          <a:p>
+            <a:pPr>
+              <a:spcAft>
+                <a:spcPts val="1000"/>
+              </a:spcAft>
+              <a:defRPr sz="1800"/>
+            </a:pPr>
+            <a:r>
+              <a:t>  ├─ Final Report (.md)</a:t>
+            </a:r>
+          </a:p>
+          <a:p>
+            <a:pPr>
+              <a:spcAft>
+                <a:spcPts val="1000"/>
+              </a:spcAft>
+              <a:defRPr sz="1800"/>
+            </a:pPr>
+            <a:r>
+              <a:t>  └─ Presentation (.pptx)</a:t>
+            </a:r>
+          </a:p>
+          <a:p>
+            <a:pPr>
+              <a:spcAft>
+                <a:spcPts val="1000"/>
+              </a:spcAft>
+              <a:defRPr sz="1800"/>
+            </a:pPr>
+          </a:p>
+          <a:p>
+            <a:pPr>
+              <a:spcAft>
+                <a:spcPts val="1000"/>
+              </a:spcAft>
+              <a:defRPr sz="1800"/>
+            </a:pPr>
+            <a:r>
+              <a:t>octcv/mdl_lib/</a:t>
+            </a:r>
+          </a:p>
+          <a:p>
+            <a:pPr>
+              <a:spcAft>
+                <a:spcPts val="1000"/>
+              </a:spcAft>
+              <a:defRPr sz="1800"/>
+            </a:pPr>
+            <a:r>
+              <a:t>  ├─ architectures.py        3 CNN architectures</a:t>
+            </a:r>
+          </a:p>
+          <a:p>
+            <a:pPr>
+              <a:spcAft>
+                <a:spcPts val="1000"/>
+              </a:spcAft>
+              <a:defRPr sz="1800"/>
+            </a:pPr>
+            <a:r>
+              <a:t>  ├─ __init__.py             XVolSet, train_model(), ModelEvaluator</a:t>
+            </a:r>
+          </a:p>
+          <a:p>
+            <a:pPr>
+              <a:spcAft>
+                <a:spcPts val="1000"/>
+              </a:spcAft>
+              <a:defRPr sz="1800"/>
+            </a:pPr>
+            <a:r>
+              <a:t>  └─ callbacks.py            LivePlot, EpochProgressBar</a:t>
             </a:r>
           </a:p>
         </p:txBody>
@@ -4257,23 +4315,6 @@
       <p:grpSpPr/>
       <p:sp>
         <p:nvSpPr>
-          <p:cNvPr id="2" name="Title 1"/>
-          <p:cNvSpPr>
-            <a:spLocks noGrp="1"/>
-          </p:cNvSpPr>
-          <p:nvPr>
-            <p:ph type="title"/>
-          </p:nvPr>
-        </p:nvSpPr>
-        <p:spPr/>
-        <p:txBody>
-          <a:bodyPr/>
-          <a:lstStyle/>
-          <a:p/>
-        </p:txBody>
-      </p:sp>
-      <p:sp>
-        <p:nvSpPr>
           <p:cNvPr id="3" name="TextBox 2"/>
           <p:cNvSpPr txBox="1"/>
           <p:nvPr/>
@@ -4302,7 +4343,7 @@
               </a:defRPr>
             </a:pPr>
             <a:r>
-              <a:t>Project Structure</a:t>
+              <a:t>References</a:t>
             </a:r>
           </a:p>
         </p:txBody>
@@ -4336,114 +4377,51 @@
               <a:defRPr sz="1800"/>
             </a:pPr>
             <a:r>
-              <a:t>PART_2/</a:t>
-            </a:r>
-          </a:p>
-          <a:p>
-            <a:pPr>
-              <a:spcAft>
-                <a:spcPts val="1000"/>
-              </a:spcAft>
-              <a:defRPr sz="1800"/>
-            </a:pPr>
-            <a:r>
-              <a:t>  ├─ DW-EDA.ipynb            Data wrangling &amp; EDA</a:t>
-            </a:r>
-          </a:p>
-          <a:p>
-            <a:pPr>
-              <a:spcAft>
-                <a:spcPts val="1000"/>
-              </a:spcAft>
-              <a:defRPr sz="1800"/>
-            </a:pPr>
-            <a:r>
-              <a:t>  ├─ PPs-Modeling.ipynb      Preprocessing + Modeling</a:t>
-            </a:r>
-          </a:p>
-          <a:p>
-            <a:pPr>
-              <a:spcAft>
-                <a:spcPts val="1000"/>
-              </a:spcAft>
-              <a:defRPr sz="1800"/>
-            </a:pPr>
-            <a:r>
-              <a:t>  ├─ model_metrics.json      Model metrics file</a:t>
-            </a:r>
-          </a:p>
-          <a:p>
-            <a:pPr>
-              <a:spcAft>
-                <a:spcPts val="1000"/>
-              </a:spcAft>
-              <a:defRPr sz="1800"/>
-            </a:pPr>
-            <a:r>
-              <a:t>  ├─ Final Report (.md)</a:t>
-            </a:r>
-          </a:p>
-          <a:p>
-            <a:pPr>
-              <a:spcAft>
-                <a:spcPts val="1000"/>
-              </a:spcAft>
-              <a:defRPr sz="1800"/>
-            </a:pPr>
-            <a:r>
-              <a:t>  └─ Presentation (.pptx)</a:t>
-            </a:r>
-          </a:p>
-          <a:p>
-            <a:pPr>
-              <a:spcAft>
-                <a:spcPts val="1000"/>
-              </a:spcAft>
-              <a:defRPr sz="1800"/>
-            </a:pPr>
-          </a:p>
-          <a:p>
-            <a:pPr>
-              <a:spcAft>
-                <a:spcPts val="1000"/>
-              </a:spcAft>
-              <a:defRPr sz="1800"/>
-            </a:pPr>
-            <a:r>
-              <a:t>octcv/mdl_lib/</a:t>
-            </a:r>
-          </a:p>
-          <a:p>
-            <a:pPr>
-              <a:spcAft>
-                <a:spcPts val="1000"/>
-              </a:spcAft>
-              <a:defRPr sz="1800"/>
-            </a:pPr>
-            <a:r>
-              <a:t>  ├─ architectures.py        3 CNN architectures</a:t>
-            </a:r>
-          </a:p>
-          <a:p>
-            <a:pPr>
-              <a:spcAft>
-                <a:spcPts val="1000"/>
-              </a:spcAft>
-              <a:defRPr sz="1800"/>
-            </a:pPr>
-            <a:r>
-              <a:t>  ├─ __init__.py             XVolSet, train_model(), ModelEvaluator</a:t>
-            </a:r>
-          </a:p>
-          <a:p>
-            <a:pPr>
-              <a:spcAft>
-                <a:spcPts val="1000"/>
-              </a:spcAft>
-              <a:defRPr sz="1800"/>
-            </a:pPr>
-            <a:r>
-              <a:t>  └─ callbacks.py            LivePlot, EpochProgressBar</a:t>
+              <a:t>[1] Ishikawa (2018). OCT volumes for glaucoma detection. Zenodo.</a:t>
+            </a:r>
+          </a:p>
+          <a:p>
+            <a:pPr>
+              <a:spcAft>
+                <a:spcPts val="1000"/>
+              </a:spcAft>
+              <a:defRPr sz="1800"/>
+            </a:pPr>
+            <a:r>
+              <a:t>[2] Maetschke et al. (2019). A feature agnostic approach for</a:t>
+            </a:r>
+          </a:p>
+          <a:p>
+            <a:pPr>
+              <a:spcAft>
+                <a:spcPts val="1000"/>
+              </a:spcAft>
+              <a:defRPr sz="1800"/>
+            </a:pPr>
+            <a:r>
+              <a:t>     glaucoma detection in OCT volumes. PLOS ONE.</a:t>
+            </a:r>
+          </a:p>
+          <a:p>
+            <a:pPr>
+              <a:spcAft>
+                <a:spcPts val="1000"/>
+              </a:spcAft>
+              <a:defRPr sz="1800"/>
+            </a:pPr>
+            <a:r>
+              <a:t>[3] He et al. (2016). Deep residual learning. CVPR.</a:t>
+            </a:r>
+          </a:p>
+          <a:p>
+            <a:pPr>
+              <a:spcAft>
+                <a:spcPts val="1000"/>
+              </a:spcAft>
+              <a:defRPr sz="1800"/>
+            </a:pPr>
+            <a:r>
+              <a:t>[4] Hu et al. (2018). Squeeze-and-excitation networks. CVPR.</a:t>
             </a:r>
           </a:p>
         </p:txBody>
@@ -4468,31 +4446,14 @@
       <p:grpSpPr/>
       <p:sp>
         <p:nvSpPr>
-          <p:cNvPr id="2" name="Title 1"/>
-          <p:cNvSpPr>
-            <a:spLocks noGrp="1"/>
-          </p:cNvSpPr>
-          <p:nvPr>
-            <p:ph type="title"/>
-          </p:nvPr>
-        </p:nvSpPr>
-        <p:spPr/>
-        <p:txBody>
-          <a:bodyPr/>
-          <a:lstStyle/>
-          <a:p/>
-        </p:txBody>
-      </p:sp>
-      <p:sp>
-        <p:nvSpPr>
           <p:cNvPr id="3" name="TextBox 2"/>
           <p:cNvSpPr txBox="1"/>
           <p:nvPr/>
         </p:nvSpPr>
         <p:spPr>
           <a:xfrm>
-            <a:off x="457200" y="274320"/>
-            <a:ext cx="10972800" cy="914400"/>
+            <a:off x="1828800" y="2743200"/>
+            <a:ext cx="8229600" cy="1828800"/>
           </a:xfrm>
           <a:prstGeom prst="rect">
             <a:avLst/>
@@ -4505,93 +4466,28 @@
           </a:bodyPr>
           <a:lstStyle/>
           <a:p>
-            <a:pPr>
-              <a:defRPr sz="3200" b="1">
+            <a:pPr algn="ctr">
+              <a:defRPr sz="4400" b="1">
                 <a:solidFill>
                   <a:srgbClr val="2C3E50"/>
                 </a:solidFill>
               </a:defRPr>
             </a:pPr>
             <a:r>
-              <a:t>References</a:t>
-            </a:r>
-          </a:p>
-        </p:txBody>
-      </p:sp>
-      <p:sp>
-        <p:nvSpPr>
-          <p:cNvPr id="4" name="TextBox 3"/>
-          <p:cNvSpPr txBox="1"/>
-          <p:nvPr/>
-        </p:nvSpPr>
-        <p:spPr>
-          <a:xfrm>
-            <a:off x="457200" y="1371600"/>
-            <a:ext cx="10972800" cy="5029200"/>
-          </a:xfrm>
-          <a:prstGeom prst="rect">
-            <a:avLst/>
-          </a:prstGeom>
-          <a:noFill/>
-        </p:spPr>
-        <p:txBody>
-          <a:bodyPr wrap="square">
-            <a:spAutoFit/>
-          </a:bodyPr>
-          <a:lstStyle/>
-          <a:p>
-            <a:pPr>
-              <a:spcAft>
-                <a:spcPts val="1000"/>
-              </a:spcAft>
-              <a:defRPr sz="1800"/>
-            </a:pPr>
-            <a:r>
-              <a:t>[1] Ishikawa (2018). OCT volumes for glaucoma detection. Zenodo.</a:t>
-            </a:r>
-          </a:p>
-          <a:p>
-            <a:pPr>
-              <a:spcAft>
-                <a:spcPts val="1000"/>
-              </a:spcAft>
-              <a:defRPr sz="1800"/>
-            </a:pPr>
-            <a:r>
-              <a:t>[2] Maetschke et al. (2019). A feature agnostic approach for</a:t>
-            </a:r>
-          </a:p>
-          <a:p>
-            <a:pPr>
-              <a:spcAft>
-                <a:spcPts val="1000"/>
-              </a:spcAft>
-              <a:defRPr sz="1800"/>
-            </a:pPr>
-            <a:r>
-              <a:t>     glaucoma detection in OCT volumes. PLOS ONE.</a:t>
-            </a:r>
-          </a:p>
-          <a:p>
-            <a:pPr>
-              <a:spcAft>
-                <a:spcPts val="1000"/>
-              </a:spcAft>
-              <a:defRPr sz="1800"/>
-            </a:pPr>
-            <a:r>
-              <a:t>[3] He et al. (2016). Deep residual learning. CVPR.</a:t>
-            </a:r>
-          </a:p>
-          <a:p>
-            <a:pPr>
-              <a:spcAft>
-                <a:spcPts val="1000"/>
-              </a:spcAft>
-              <a:defRPr sz="1800"/>
-            </a:pPr>
-            <a:r>
-              <a:t>[4] Hu et al. (2018). Squeeze-and-excitation networks. CVPR.</a:t>
+              <a:t>Thank You</a:t>
+            </a:r>
+          </a:p>
+          <a:p/>
+          <a:p>
+            <a:pPr algn="ctr">
+              <a:defRPr sz="2800">
+                <a:solidFill>
+                  <a:srgbClr val="7F8C8D"/>
+                </a:solidFill>
+              </a:defRPr>
+            </a:pPr>
+            <a:r>
+              <a:t>Questions?</a:t>
             </a:r>
           </a:p>
         </p:txBody>
@@ -4616,23 +4512,6 @@
       <p:grpSpPr/>
       <p:sp>
         <p:nvSpPr>
-          <p:cNvPr id="2" name="Title 1"/>
-          <p:cNvSpPr>
-            <a:spLocks noGrp="1"/>
-          </p:cNvSpPr>
-          <p:nvPr>
-            <p:ph type="title"/>
-          </p:nvPr>
-        </p:nvSpPr>
-        <p:spPr/>
-        <p:txBody>
-          <a:bodyPr/>
-          <a:lstStyle/>
-          <a:p/>
-        </p:txBody>
-      </p:sp>
-      <p:sp>
-        <p:nvSpPr>
           <p:cNvPr id="3" name="TextBox 2"/>
           <p:cNvSpPr txBox="1"/>
           <p:nvPr/>
@@ -4762,89 +4641,6 @@
             </a:pPr>
             <a:r>
               <a:t>7. Future Directions</a:t>
-            </a:r>
-          </a:p>
-        </p:txBody>
-      </p:sp>
-    </p:spTree>
-  </p:cSld>
-  <p:clrMapOvr>
-    <a:masterClrMapping/>
-  </p:clrMapOvr>
-</p:sld>
-</file>
-
-<file path=ppt/slides/slide20.xml><?xml version="1.0" encoding="utf-8"?>
-<p:sld xmlns:a="http://schemas.openxmlformats.org/drawingml/2006/main" xmlns:p="http://schemas.openxmlformats.org/presentationml/2006/main" xmlns:r="http://schemas.openxmlformats.org/officeDocument/2006/relationships">
-  <p:cSld>
-    <p:spTree>
-      <p:nvGrpSpPr>
-        <p:cNvPr id="1" name=""/>
-        <p:cNvGrpSpPr/>
-        <p:nvPr/>
-      </p:nvGrpSpPr>
-      <p:grpSpPr/>
-      <p:sp>
-        <p:nvSpPr>
-          <p:cNvPr id="2" name="Title 1"/>
-          <p:cNvSpPr>
-            <a:spLocks noGrp="1"/>
-          </p:cNvSpPr>
-          <p:nvPr>
-            <p:ph type="title"/>
-          </p:nvPr>
-        </p:nvSpPr>
-        <p:spPr/>
-        <p:txBody>
-          <a:bodyPr/>
-          <a:lstStyle/>
-          <a:p/>
-        </p:txBody>
-      </p:sp>
-      <p:sp>
-        <p:nvSpPr>
-          <p:cNvPr id="3" name="TextBox 2"/>
-          <p:cNvSpPr txBox="1"/>
-          <p:nvPr/>
-        </p:nvSpPr>
-        <p:spPr>
-          <a:xfrm>
-            <a:off x="1828800" y="2743200"/>
-            <a:ext cx="8229600" cy="1828800"/>
-          </a:xfrm>
-          <a:prstGeom prst="rect">
-            <a:avLst/>
-          </a:prstGeom>
-          <a:noFill/>
-        </p:spPr>
-        <p:txBody>
-          <a:bodyPr wrap="none">
-            <a:spAutoFit/>
-          </a:bodyPr>
-          <a:lstStyle/>
-          <a:p>
-            <a:pPr algn="ctr">
-              <a:defRPr sz="4400" b="1">
-                <a:solidFill>
-                  <a:srgbClr val="2C3E50"/>
-                </a:solidFill>
-              </a:defRPr>
-            </a:pPr>
-            <a:r>
-              <a:t>Thank You</a:t>
-            </a:r>
-          </a:p>
-          <a:p/>
-          <a:p>
-            <a:pPr algn="ctr">
-              <a:defRPr sz="2800">
-                <a:solidFill>
-                  <a:srgbClr val="7F8C8D"/>
-                </a:solidFill>
-              </a:defRPr>
-            </a:pPr>
-            <a:r>
-              <a:t>Questions?</a:t>
             </a:r>
           </a:p>
         </p:txBody>
@@ -4869,23 +4665,6 @@
       <p:grpSpPr/>
       <p:sp>
         <p:nvSpPr>
-          <p:cNvPr id="2" name="Title 1"/>
-          <p:cNvSpPr>
-            <a:spLocks noGrp="1"/>
-          </p:cNvSpPr>
-          <p:nvPr>
-            <p:ph type="title"/>
-          </p:nvPr>
-        </p:nvSpPr>
-        <p:spPr/>
-        <p:txBody>
-          <a:bodyPr/>
-          <a:lstStyle/>
-          <a:p/>
-        </p:txBody>
-      </p:sp>
-      <p:sp>
-        <p:nvSpPr>
           <p:cNvPr id="3" name="TextBox 2"/>
           <p:cNvSpPr txBox="1"/>
           <p:nvPr/>
@@ -5036,23 +4815,6 @@
       <p:grpSpPr/>
       <p:sp>
         <p:nvSpPr>
-          <p:cNvPr id="2" name="Title 1"/>
-          <p:cNvSpPr>
-            <a:spLocks noGrp="1"/>
-          </p:cNvSpPr>
-          <p:nvPr>
-            <p:ph type="title"/>
-          </p:nvPr>
-        </p:nvSpPr>
-        <p:spPr/>
-        <p:txBody>
-          <a:bodyPr/>
-          <a:lstStyle/>
-          <a:p/>
-        </p:txBody>
-      </p:sp>
-      <p:sp>
-        <p:nvSpPr>
           <p:cNvPr id="3" name="TextBox 2"/>
           <p:cNvSpPr txBox="1"/>
           <p:nvPr/>
@@ -5193,23 +4955,6 @@
         <p:nvPr/>
       </p:nvGrpSpPr>
       <p:grpSpPr/>
-      <p:sp>
-        <p:nvSpPr>
-          <p:cNvPr id="2" name="Title 1"/>
-          <p:cNvSpPr>
-            <a:spLocks noGrp="1"/>
-          </p:cNvSpPr>
-          <p:nvPr>
-            <p:ph type="title"/>
-          </p:nvPr>
-        </p:nvSpPr>
-        <p:spPr/>
-        <p:txBody>
-          <a:bodyPr/>
-          <a:lstStyle/>
-          <a:p/>
-        </p:txBody>
-      </p:sp>
       <p:sp>
         <p:nvSpPr>
           <p:cNvPr id="3" name="TextBox 2"/>
@@ -5367,23 +5112,6 @@
       <p:grpSpPr/>
       <p:sp>
         <p:nvSpPr>
-          <p:cNvPr id="2" name="Title 1"/>
-          <p:cNvSpPr>
-            <a:spLocks noGrp="1"/>
-          </p:cNvSpPr>
-          <p:nvPr>
-            <p:ph type="title"/>
-          </p:nvPr>
-        </p:nvSpPr>
-        <p:spPr/>
-        <p:txBody>
-          <a:bodyPr/>
-          <a:lstStyle/>
-          <a:p/>
-        </p:txBody>
-      </p:sp>
-      <p:sp>
-        <p:nvSpPr>
           <p:cNvPr id="3" name="TextBox 2"/>
           <p:cNvSpPr txBox="1"/>
           <p:nvPr/>
@@ -5539,23 +5267,6 @@
       <p:grpSpPr/>
       <p:sp>
         <p:nvSpPr>
-          <p:cNvPr id="2" name="Title 1"/>
-          <p:cNvSpPr>
-            <a:spLocks noGrp="1"/>
-          </p:cNvSpPr>
-          <p:nvPr>
-            <p:ph type="title"/>
-          </p:nvPr>
-        </p:nvSpPr>
-        <p:spPr/>
-        <p:txBody>
-          <a:bodyPr/>
-          <a:lstStyle/>
-          <a:p/>
-        </p:txBody>
-      </p:sp>
-      <p:sp>
-        <p:nvSpPr>
           <p:cNvPr id="3" name="TextBox 2"/>
           <p:cNvSpPr txBox="1"/>
           <p:nvPr/>
@@ -5633,23 +5344,6 @@
       <p:grpSpPr/>
       <p:sp>
         <p:nvSpPr>
-          <p:cNvPr id="2" name="Title 1"/>
-          <p:cNvSpPr>
-            <a:spLocks noGrp="1"/>
-          </p:cNvSpPr>
-          <p:nvPr>
-            <p:ph type="title"/>
-          </p:nvPr>
-        </p:nvSpPr>
-        <p:spPr/>
-        <p:txBody>
-          <a:bodyPr/>
-          <a:lstStyle/>
-          <a:p/>
-        </p:txBody>
-      </p:sp>
-      <p:sp>
-        <p:nvSpPr>
           <p:cNvPr id="3" name="TextBox 2"/>
           <p:cNvSpPr txBox="1"/>
           <p:nvPr/>
@@ -5725,23 +5419,6 @@
         <p:nvPr/>
       </p:nvGrpSpPr>
       <p:grpSpPr/>
-      <p:sp>
-        <p:nvSpPr>
-          <p:cNvPr id="2" name="Title 1"/>
-          <p:cNvSpPr>
-            <a:spLocks noGrp="1"/>
-          </p:cNvSpPr>
-          <p:nvPr>
-            <p:ph type="title"/>
-          </p:nvPr>
-        </p:nvSpPr>
-        <p:spPr/>
-        <p:txBody>
-          <a:bodyPr/>
-          <a:lstStyle/>
-          <a:p/>
-        </p:txBody>
-      </p:sp>
       <p:sp>
         <p:nvSpPr>
           <p:cNvPr id="3" name="TextBox 2"/>

</xml_diff>